<commit_message>
updates to stretch not strain
</commit_message>
<xml_diff>
--- a/decks/stretch-not-strain-lesson-v2.pptx
+++ b/decks/stretch-not-strain-lesson-v2.pptx
@@ -1010,7 +1010,7 @@
           <a:lstStyle/>
           <a:p>
             <a:r>
-              <a:t>4 MINUTES. Invite, don't assign: "Which move will you try?" The student card on this slide gives students the same language (stretch vs. shutdown, the hint ladder, the 5-minute rule) and who to talk to. Teachers can share it after naming the idea in class. If the department wants a follow-up, collect anonymous notes on which moves worked.</a:t>
+              <a:t>4 MINUTES. Invite, don't assign: "Which move will you try?" The quick reference on this slide puts stretch vs. shutdown, the five moves and the key phrases on one page teachers can print or keep open. If the department wants a follow-up, collect anonymous notes on which moves worked.</a:t>
             </a:r>
           </a:p>
         </p:txBody>
@@ -4875,7 +4875,7 @@
                 </a:solidFill>
                 <a:latin typeface="Source Serif 4"/>
               </a:rPr>
-              <a:t>The student card link (last slide) for teachers to share with classes</a:t>
+              <a:t>The faculty quick reference (last slide): one page to print or keep open</a:t>
             </a:r>
           </a:p>
         </p:txBody>
@@ -5162,7 +5162,7 @@
                 </a:solidFill>
                 <a:latin typeface="Source Serif 4"/>
               </a:rPr>
-              <a:t>Thirty minutes: the question (3), the 80% finding and worked examples (6), stretch or shutdown (5), wise feedback and reappraisal (6), five moves (5), one move this week (5). Share the student card link afterward.</a:t>
+              <a:t>Thirty minutes: the question (3), the 80% finding and worked examples (6), stretch or shutdown (5), wise feedback and reappraisal (6), five moves (5), one move this week (5). Share the faculty quick reference afterward.</a:t>
             </a:r>
           </a:p>
         </p:txBody>
@@ -10034,7 +10034,7 @@
                 </a:solidFill>
                 <a:latin typeface="Inter Tight"/>
               </a:rPr>
-              <a:t>STUDENT CARD TEACHERS CAN SHARE</a:t>
+              <a:t>FACULTY QUICK REFERENCE</a:t>
             </a:r>
           </a:p>
         </p:txBody>
@@ -10073,7 +10073,7 @@
                 </a:solidFill>
                 <a:latin typeface="Inter Tight"/>
               </a:rPr>
-              <a:t>https://rmwtoolkit.github.io/bcds-toolkit/when-it-gets-hard-high-school.html</a:t>
+              <a:t>https://rmwtoolkit.github.io/bcds-toolkit/stretch-not-strain-faculty-card.html</a:t>
             </a:r>
           </a:p>
         </p:txBody>

</xml_diff>